<commit_message>
Update project authorship: Sole developer J. Sai Satyan, remove teammate references and IDs
</commit_message>
<xml_diff>
--- a/BookVerse_Academic_Poster.pptx
+++ b/BookVerse_Academic_Poster.pptx
@@ -3204,11 +3204,7 @@
               </a:defRPr>
             </a:pPr>
             <a:r>
-              <a:t>Team ID: BV-PBL-042  |  Section: S-14 (CSE)  |  Guide: Dr. K. V. Ramanathan</a:t>
-            </a:r>
-            <a:br/>
-            <a:r>
-              <a:t>Members: J. SAI SATYAN (2520030088)  ·  M. TANMAYEE (2520030339)  ·  K. DEVIKA (2520030329)</a:t>
+              <a:t>Team ID: BV-PBL-042  |  Section: S-14 (CSE)  |  Author: J. SAI SATYAN  |  Guide: Dr. K. V. Ramanathan</a:t>
             </a:r>
           </a:p>
         </p:txBody>

</xml_diff>